<commit_message>
Humanised deck, second pass: plain-language labels, headers and appendix wording
Co-Authored-By: Claude Opus 5.5 <noreply@anthropic.com>
Claude-Session: https://claude.ai/code/session_01PZ8XgsWarJGqs7eKwNE5g5
</commit_message>
<xml_diff>
--- a/deck/Team G27 Final Humanised.pptx
+++ b/deck/Team G27 Final Humanised.pptx
@@ -5824,7 +5824,7 @@
                 <a:ea typeface="Inter" pitchFamily="34" charset="-122"/>
                 <a:cs typeface="Inter" pitchFamily="34" charset="-120"/>
               </a:rPr>
-              <a:t>Results in weeks, $0 incremental</a:t>
+              <a:t>Results in weeks, at no extra cost</a:t>
             </a:r>
             <a:endParaRPr lang="en-US" sz="1050" dirty="0"/>
           </a:p>
@@ -5992,7 +5992,7 @@
                 <a:ea typeface="Inter" pitchFamily="34" charset="-122"/>
                 <a:cs typeface="Inter" pitchFamily="34" charset="-120"/>
               </a:rPr>
-              <a:t>Proves fast</a:t>
+              <a:t>Shows results fast</a:t>
             </a:r>
             <a:endParaRPr lang="en-US" sz="1200" dirty="0"/>
           </a:p>
@@ -6255,7 +6255,7 @@
                 <a:ea typeface="Inter" pitchFamily="34" charset="-122"/>
                 <a:cs typeface="Inter" pitchFamily="34" charset="-120"/>
               </a:rPr>
-              <a:t>Lowest cost per touch; insulated from ATT</a:t>
+              <a:t>Cheapest way to reach people; unaffected by iPhone privacy limits</a:t>
             </a:r>
             <a:endParaRPr lang="en-US" sz="1050" dirty="0"/>
           </a:p>
@@ -6423,7 +6423,7 @@
                 <a:ea typeface="Inter" pitchFamily="34" charset="-122"/>
                 <a:cs typeface="Inter" pitchFamily="34" charset="-120"/>
               </a:rPr>
-              <a:t>Builds it</a:t>
+              <a:t>Builds the habit</a:t>
             </a:r>
             <a:endParaRPr lang="en-US" sz="1200" dirty="0"/>
           </a:p>
@@ -6440,7 +6440,7 @@
                 <a:ea typeface="Inter" pitchFamily="34" charset="-122"/>
                 <a:cs typeface="Inter" pitchFamily="34" charset="-120"/>
               </a:rPr>
-              <a:t>Capture grows the list; journeys earn order two</a:t>
+              <a:t>We grow the list, and follow-ups earn the second order</a:t>
             </a:r>
             <a:endParaRPr lang="en-US" sz="1200" dirty="0"/>
           </a:p>
@@ -6854,7 +6854,7 @@
                 <a:ea typeface="Inter" pitchFamily="34" charset="-122"/>
                 <a:cs typeface="Inter" pitchFamily="34" charset="-120"/>
               </a:rPr>
-              <a:t>Proves it</a:t>
+              <a:t>Shows what works</a:t>
             </a:r>
             <a:endParaRPr lang="en-US" sz="1200" dirty="0"/>
           </a:p>
@@ -6871,7 +6871,7 @@
                 <a:ea typeface="Inter" pitchFamily="34" charset="-122"/>
                 <a:cs typeface="Inter" pitchFamily="34" charset="-120"/>
               </a:rPr>
-              <a:t>Runs from day 1 and decides every tranche</a:t>
+              <a:t>Runs from day one and decides each budget move</a:t>
             </a:r>
             <a:endParaRPr lang="en-US" sz="1200" dirty="0"/>
           </a:p>
@@ -7652,7 +7652,7 @@
                 <a:ea typeface="Inter" pitchFamily="34" charset="-122"/>
                 <a:cs typeface="Inter" pitchFamily="34" charset="-120"/>
               </a:rPr>
-              <a:t>Spend may pay for demand that comes anyway</a:t>
+              <a:t>We may be paying for sales we'd get anyway</a:t>
             </a:r>
             <a:endParaRPr lang="en-US" sz="1200" dirty="0"/>
           </a:p>
@@ -8346,7 +8346,7 @@
                 <a:ea typeface="Inter" pitchFamily="34" charset="-122"/>
                 <a:cs typeface="Inter" pitchFamily="34" charset="-120"/>
               </a:rPr>
-              <a:t>The purchase leaks</a:t>
+              <a:t>Shoppers drop off before buying</a:t>
             </a:r>
             <a:endParaRPr lang="en-US" sz="1200" dirty="0"/>
           </a:p>
@@ -8698,7 +8698,7 @@
                 <a:ea typeface="Inter" pitchFamily="34" charset="-122"/>
                 <a:cs typeface="Inter" pitchFamily="34" charset="-120"/>
               </a:rPr>
-              <a:t>Found, not yet trusted</a:t>
+              <a:t>Found us, but don't trust us yet</a:t>
             </a:r>
             <a:endParaRPr lang="en-US" sz="1200" dirty="0"/>
           </a:p>
@@ -8842,7 +8842,7 @@
                 <a:ea typeface="Inter" pitchFamily="34" charset="-122"/>
                 <a:cs typeface="Inter" pitchFamily="34" charset="-120"/>
               </a:rPr>
-              <a:t>Trust thread, all levers</a:t>
+              <a:t>Trust, in every lever</a:t>
             </a:r>
             <a:endParaRPr lang="en-US" sz="1100" dirty="0"/>
           </a:p>
@@ -10226,7 +10226,7 @@
                 <a:ea typeface="Inter" pitchFamily="34" charset="-122"/>
                 <a:cs typeface="Inter" pitchFamily="34" charset="-120"/>
               </a:rPr>
-              <a:t>Unfinished task fades</a:t>
+              <a:t>An unfinished purchase is forgotten</a:t>
             </a:r>
             <a:endParaRPr lang="en-US" sz="1050" dirty="0"/>
           </a:p>
@@ -10577,7 +10577,7 @@
                 <a:ea typeface="Inter" pitchFamily="34" charset="-122"/>
                 <a:cs typeface="Inter" pitchFamily="34" charset="-120"/>
               </a:rPr>
-              <a:t>Default effect</a:t>
+              <a:t>People stick with the default</a:t>
             </a:r>
             <a:endParaRPr lang="en-US" sz="1050" dirty="0"/>
           </a:p>
@@ -10928,7 +10928,7 @@
                 <a:ea typeface="Inter" pitchFamily="34" charset="-122"/>
                 <a:cs typeface="Inter" pitchFamily="34" charset="-120"/>
               </a:rPr>
-              <a:t>Peak-end, endowment</a:t>
+              <a:t>Unboxing is the high point</a:t>
             </a:r>
             <a:endParaRPr lang="en-US" sz="1050" dirty="0"/>
           </a:p>
@@ -11279,7 +11279,7 @@
                 <a:ea typeface="Inter" pitchFamily="34" charset="-122"/>
                 <a:cs typeface="Inter" pitchFamily="34" charset="-120"/>
               </a:rPr>
-              <a:t>Habit formation</a:t>
+              <a:t>Habits form early</a:t>
             </a:r>
             <a:endParaRPr lang="en-US" sz="1050" dirty="0"/>
           </a:p>
@@ -11630,7 +11630,7 @@
                 <a:ea typeface="Inter" pitchFamily="34" charset="-122"/>
                 <a:cs typeface="Inter" pitchFamily="34" charset="-120"/>
               </a:rPr>
-              <a:t>Mental accounting</a:t>
+              <a:t>One purchase feels like a category</a:t>
             </a:r>
             <a:endParaRPr lang="en-US" sz="1050" dirty="0"/>
           </a:p>
@@ -16282,7 +16282,7 @@
                 <a:ea typeface="Inter" pitchFamily="34" charset="-122"/>
                 <a:cs typeface="Inter" pitchFamily="34" charset="-120"/>
               </a:rPr>
-              <a:t>Frequency cap</a:t>
+              <a:t>Limit on how often we show ads</a:t>
             </a:r>
             <a:endParaRPr lang="en-US" sz="1050" dirty="0"/>
           </a:p>
@@ -16299,7 +16299,7 @@
                 <a:ea typeface="Inter" pitchFamily="34" charset="-122"/>
                 <a:cs typeface="Inter" pitchFamily="34" charset="-120"/>
               </a:rPr>
-              <a:t>per person, across platforms</a:t>
+              <a:t>per person, on every platform</a:t>
             </a:r>
             <a:endParaRPr lang="en-US" sz="1050" dirty="0"/>
           </a:p>
@@ -16372,7 +16372,7 @@
                 <a:ea typeface="Inter" pitchFamily="34" charset="-122"/>
                 <a:cs typeface="Inter" pitchFamily="34" charset="-120"/>
               </a:rPr>
-              <a:t>Prospecting exclusions</a:t>
+              <a:t>Keep existing buyers out of new-customer ads</a:t>
             </a:r>
             <a:endParaRPr lang="en-US" sz="1050" dirty="0"/>
           </a:p>
@@ -16389,7 +16389,7 @@
                 <a:ea typeface="Inter" pitchFamily="34" charset="-122"/>
                 <a:cs typeface="Inter" pitchFamily="34" charset="-120"/>
               </a:rPr>
-              <a:t>existing buyers kept out of new-customer campaigns</a:t>
+              <a:t>so we don't pay to win them again</a:t>
             </a:r>
             <a:endParaRPr lang="en-US" sz="1050" dirty="0"/>
           </a:p>
@@ -16827,7 +16827,7 @@
                 <a:ea typeface="Inter" pitchFamily="34" charset="-122"/>
                 <a:cs typeface="Inter" pitchFamily="34" charset="-120"/>
               </a:rPr>
-              <a:t>Prove: incremental orders per retargeting $ vs holdout</a:t>
+              <a:t>We measure: extra orders per retargeting $ against the holdout</a:t>
             </a:r>
             <a:endParaRPr lang="en-US" sz="950" dirty="0"/>
           </a:p>
@@ -17539,7 +17539,7 @@
                 <a:ea typeface="Inter" pitchFamily="34" charset="-122"/>
                 <a:cs typeface="Inter" pitchFamily="34" charset="-120"/>
               </a:rPr>
-              <a:t>Read Fallout, Flow, Cohort Table and Attribution IQ on one stitched person ID</a:t>
+              <a:t>Read Fallout, Flow, Cohort Table and Attribution IQ for each person across all channels</a:t>
             </a:r>
             <a:endParaRPr lang="en-US" sz="1000" dirty="0"/>
           </a:p>
@@ -17935,7 +17935,7 @@
                 <a:ea typeface="Inter" pitchFamily="34" charset="-122"/>
                 <a:cs typeface="Inter" pitchFamily="34" charset="-120"/>
               </a:rPr>
-              <a:t>Turn findings into saved CJA segments: abandoners, engaged, cashmere-first, recent buyers</a:t>
+              <a:t>Turn what we learn into saved CJA groups: cart abandoners, engaged buyers, cashmere-first buyers, recent buyers</a:t>
             </a:r>
             <a:endParaRPr lang="en-US" sz="1000" dirty="0"/>
           </a:p>
@@ -18331,7 +18331,7 @@
                 <a:ea typeface="Inter" pitchFamily="34" charset="-122"/>
                 <a:cs typeface="Inter" pitchFamily="34" charset="-120"/>
               </a:rPr>
-              <a:t>Send segments to lifecycle journeys and to paid-media suppression lists</a:t>
+              <a:t>Send those groups to our follow-up messages and to the ad platforms' exclusion lists</a:t>
             </a:r>
             <a:endParaRPr lang="en-US" sz="1000" dirty="0"/>
           </a:p>
@@ -18727,7 +18727,7 @@
                 <a:ea typeface="Inter" pitchFamily="34" charset="-122"/>
                 <a:cs typeface="Inter" pitchFamily="34" charset="-120"/>
               </a:rPr>
-              <a:t>Read every move against a randomized holdout: 10% in the South pilot</a:t>
+              <a:t>Check every move against a random 10% holdout in the South pilot</a:t>
             </a:r>
             <a:endParaRPr lang="en-US" sz="1000" dirty="0"/>
           </a:p>
@@ -19123,7 +19123,7 @@
                 <a:ea typeface="Inter" pitchFamily="34" charset="-122"/>
                 <a:cs typeface="Inter" pitchFamily="34" charset="-120"/>
               </a:rPr>
-              <a:t>Move money across lines only when the holdout proves it; otherwise it stays</a:t>
+              <a:t>Move money between budget lines only when the holdout proves it; otherwise it stays put</a:t>
             </a:r>
             <a:endParaRPr lang="en-US" sz="1000" dirty="0"/>
           </a:p>
@@ -19923,7 +19923,7 @@
                   <a:srgbClr val="002060"/>
                 </a:solidFill>
               </a:rPr>
-              <a:t>Situation  </a:t>
+              <a:t>Where Quince is  </a:t>
             </a:r>
             <a:r>
               <a:rPr lang="en-GB" sz="1200" dirty="0">
@@ -19939,7 +19939,7 @@
                   <a:srgbClr val="DC2626"/>
                 </a:solidFill>
               </a:rPr>
-              <a:t>Complication  </a:t>
+              <a:t>What's going wrong  </a:t>
             </a:r>
             <a:r>
               <a:rPr lang="en-GB" sz="1200" dirty="0">
@@ -21322,7 +21322,7 @@
                 </a:solidFill>
                 <a:latin typeface="Inter"/>
               </a:rPr>
-              <a:t>blended CAC on Exhibit J's definition, $62 → ~$54 · target −10%</a:t>
+              <a:t>cost to win a customer on Exhibit J's definition, $62 → ~$54 · target −10%</a:t>
             </a:r>
           </a:p>
         </p:txBody>
@@ -34389,7 +34389,7 @@
                 <a:ea typeface="Inter" pitchFamily="34" charset="-122"/>
                 <a:cs typeface="Inter" pitchFamily="34" charset="-120"/>
               </a:rPr>
-              <a:t>Selection bias inflates lift</a:t>
+              <a:t>Results look better than they are</a:t>
             </a:r>
             <a:endParaRPr lang="en-US" sz="1100" dirty="0"/>
           </a:p>
@@ -34577,7 +34577,7 @@
                 <a:ea typeface="Inter" pitchFamily="34" charset="-122"/>
                 <a:cs typeface="Inter" pitchFamily="34" charset="-120"/>
               </a:rPr>
-              <a:t>Channel owners resist cuts</a:t>
+              <a:t>Channel owners push back on cuts</a:t>
             </a:r>
             <a:endParaRPr lang="en-US" sz="1100" dirty="0"/>
           </a:p>
@@ -35329,7 +35329,7 @@
                 <a:ea typeface="Inter" pitchFamily="34" charset="-122"/>
                 <a:cs typeface="Inter" pitchFamily="34" charset="-120"/>
               </a:rPr>
-              <a:t>Platform or signal shock</a:t>
+              <a:t>A platform change cuts what we can see</a:t>
             </a:r>
             <a:endParaRPr lang="en-US" sz="1100" dirty="0"/>
           </a:p>
@@ -35893,7 +35893,7 @@
                 <a:ea typeface="Inter" pitchFamily="34" charset="-122"/>
                 <a:cs typeface="Inter" pitchFamily="34" charset="-120"/>
               </a:rPr>
-              <a:t>Activation set-up slips</a:t>
+              <a:t>Connecting CJA to the ad platforms runs late</a:t>
             </a:r>
             <a:endParaRPr lang="en-US" sz="1100" dirty="0"/>
           </a:p>
@@ -40340,7 +40340,7 @@
                 </a:solidFill>
                 <a:latin typeface="Inter"/>
               </a:rPr>
-              <a:t>THE MARKET</a:t>
+              <a:t>THE MARKET WE'RE IN</a:t>
             </a:r>
           </a:p>
         </p:txBody>
@@ -40732,7 +40732,7 @@
                 </a:solidFill>
                 <a:latin typeface="Inter"/>
               </a:rPr>
-              <a:t>FOUR FORCES RAISE THE COST OF RENTING REACH</a:t>
+              <a:t>FOUR THINGS MAKING RENTED REACH MORE EXPENSIVE</a:t>
             </a:r>
           </a:p>
         </p:txBody>
@@ -41021,7 +41021,7 @@
                 </a:solidFill>
                 <a:latin typeface="Inter"/>
               </a:rPr>
-              <a:t>Dearer auctions</a:t>
+              <a:t>Ads cost more</a:t>
             </a:r>
           </a:p>
           <a:p>
@@ -41191,7 +41191,7 @@
                 </a:solidFill>
                 <a:latin typeface="Inter"/>
               </a:rPr>
-              <a:t>Misread credit</a:t>
+              <a:t>Ads get too much credit</a:t>
             </a:r>
           </a:p>
           <a:p>
@@ -41567,7 +41567,7 @@
                 </a:solidFill>
                 <a:latin typeface="Inter"/>
               </a:rPr>
-              <a:t>Result for Quince: blended CAC</a:t>
+              <a:t>What it means for Quince: cost to win a customer</a:t>
             </a:r>
           </a:p>
           <a:p>
@@ -41618,7 +41618,7 @@
                 </a:solidFill>
                 <a:latin typeface="Inter"/>
               </a:rPr>
-              <a:t>RENTED CHANNELS COST MOST AND KEEP LEAST · EXHIBITS D, G (ILLUSTRATIVE)</a:t>
+              <a:t>THE CHANNELS WE RENT COST THE MOST AND KEEP THE FEWEST · EXHIBITS D, G (ILLUSTRATIVE)</a:t>
             </a:r>
           </a:p>
         </p:txBody>
@@ -43215,7 +43215,7 @@
                 </a:solidFill>
                 <a:latin typeface="Inter"/>
               </a:rPr>
-              <a:t>Organic is earned, not bought.</a:t>
+              <a:t>Organic customers are earned, not bought.</a:t>
             </a:r>
           </a:p>
         </p:txBody>
@@ -45620,7 +45620,7 @@
                 <a:ea typeface="Inter" pitchFamily="34" charset="-122"/>
                 <a:cs typeface="Inter" pitchFamily="34" charset="-120"/>
               </a:rPr>
-              <a:t>When, and what next</a:t>
+              <a:t>When, and what they buy next</a:t>
             </a:r>
             <a:endParaRPr lang="en-US" sz="1250" dirty="0"/>
           </a:p>
@@ -48567,7 +48567,7 @@
                 <a:ea typeface="Inter" pitchFamily="34" charset="-122"/>
                 <a:cs typeface="Inter" pitchFamily="34" charset="-120"/>
               </a:rPr>
-              <a:t>What a rival can copy, and how fast</a:t>
+              <a:t>What a rival could copy, and how fast</a:t>
             </a:r>
             <a:endParaRPr lang="en-US" sz="1100" dirty="0"/>
           </a:p>
@@ -48748,7 +48748,7 @@
                 <a:ea typeface="Inter" pitchFamily="34" charset="-122"/>
                 <a:cs typeface="Inter" pitchFamily="34" charset="-120"/>
               </a:rPr>
-              <a:t>Journeys and suppression lists</a:t>
+              <a:t>Follow-up messages and ad exclusions</a:t>
             </a:r>
             <a:endParaRPr lang="en-US" sz="950" dirty="0"/>
           </a:p>
@@ -50637,7 +50637,7 @@
                 </a:solidFill>
                 <a:latin typeface="Inter"/>
               </a:rPr>
-              <a:t>READY TODAY</a:t>
+              <a:t>WHAT QUINCE ALREADY HAS</a:t>
             </a:r>
           </a:p>
         </p:txBody>
@@ -50910,7 +50910,7 @@
                 </a:solidFill>
                 <a:latin typeface="Inter"/>
               </a:rPr>
-              <a:t>CJA audiences to journeys and ad platforms</a:t>
+              <a:t>Getting CJA audiences into messages and ad platforms</a:t>
             </a:r>
           </a:p>
         </p:txBody>
@@ -51090,7 +51090,7 @@
                 </a:solidFill>
                 <a:latin typeface="Inter"/>
               </a:rPr>
-              <a:t>Lifecycle team and creative</a:t>
+              <a:t>A team for follow-up messages, plus fresh creative</a:t>
             </a:r>
           </a:p>
           <a:p>
@@ -51286,7 +51286,7 @@
                 </a:solidFill>
                 <a:latin typeface="Inter"/>
               </a:rPr>
-              <a:t>Growth–analytics alignment</a:t>
+              <a:t>Marketing and analytics working as one</a:t>
             </a:r>
           </a:p>
           <a:p>
@@ -51302,7 +51302,7 @@
                 </a:solidFill>
                 <a:latin typeface="Inter"/>
               </a:rPr>
-              <a:t>Weekly holdout council; incremental scorecards</a:t>
+              <a:t>A weekly meeting that judges every channel on what it truly adds</a:t>
             </a:r>
           </a:p>
         </p:txBody>
@@ -51744,7 +51744,7 @@
                 </a:solidFill>
                 <a:latin typeface="Inter"/>
               </a:rPr>
-              <a:t>LEVER · WHY</a:t>
+              <a:t>WHAT WE DO · WHY</a:t>
             </a:r>
           </a:p>
         </p:txBody>
@@ -51814,7 +51814,7 @@
                 </a:solidFill>
                 <a:latin typeface="Inter"/>
               </a:rPr>
-              <a:t>GATE 1 PASS MARK, MONTH 3</a:t>
+              <a:t>WHAT COUNTS AS SUCCESS AT MONTH 3</a:t>
             </a:r>
           </a:p>
         </p:txBody>
@@ -51849,7 +51849,7 @@
                 </a:solidFill>
                 <a:latin typeface="Inter"/>
               </a:rPr>
-              <a:t>OWNER · PAID FROM</a:t>
+              <a:t>WHO OWNS IT · WHO PAYS</a:t>
             </a:r>
           </a:p>
         </p:txBody>
@@ -52162,7 +52162,7 @@
                 </a:solidFill>
                 <a:latin typeface="Inter"/>
               </a:rPr>
-              <a:t>Engaged share ≥ 2× holdout</a:t>
+              <a:t>Twice as many buyers engaged as in the holdout</a:t>
             </a:r>
           </a:p>
           <a:p>
@@ -52542,7 +52542,7 @@
                 </a:solidFill>
                 <a:latin typeface="Inter"/>
               </a:rPr>
-              <a:t>30-day repeat +2 pts vs holdout</a:t>
+              <a:t>30-day repeat 2 points above the holdout</a:t>
             </a:r>
           </a:p>
           <a:p>
@@ -52558,7 +52558,7 @@
                 </a:solidFill>
                 <a:latin typeface="Inter"/>
               </a:rPr>
-              <a:t>read weekly on the CJA Cohort Table</a:t>
+              <a:t>we check it weekly in the CJA Cohort Table</a:t>
             </a:r>
           </a:p>
         </p:txBody>
@@ -52922,7 +52922,7 @@
                 </a:solidFill>
                 <a:latin typeface="Inter"/>
               </a:rPr>
-              <a:t>Orders per $ ≥ holdout</a:t>
+              <a:t>At least as many orders per $ as the holdout</a:t>
             </a:r>
           </a:p>
           <a:p>
@@ -53172,7 +53172,7 @@
                 </a:solidFill>
                 <a:latin typeface="Inter"/>
               </a:rPr>
-              <a:t>3 flagships; 11 programs wait</a:t>
+              <a:t>3 flagships start; 11 wait</a:t>
             </a:r>
           </a:p>
         </p:txBody>
@@ -53396,7 +53396,7 @@
                 </a:solidFill>
                 <a:latin typeface="Inter"/>
               </a:rPr>
-              <a:t>if the branded geo test proves it</a:t>
+              <a:t>if a regional search test proves it</a:t>
             </a:r>
           </a:p>
         </p:txBody>
@@ -53588,7 +53588,7 @@
                 </a:solidFill>
                 <a:latin typeface="Inter"/>
               </a:rPr>
-              <a:t>Gate 2 → target</a:t>
+              <a:t>Month 9 check → target</a:t>
             </a:r>
           </a:p>
           <a:p>

</xml_diff>